<commit_message>
S5_Projektbericht: Chapter 2 finished
</commit_message>
<xml_diff>
--- a/Projektbericht/abbildungen/koordinatensysteme_seitenansicht_v02.pptx
+++ b/Projektbericht/abbildungen/koordinatensysteme_seitenansicht_v02.pptx
@@ -107,6 +107,11 @@
       </a:defRPr>
     </a:lvl9pPr>
   </p:defaultTextStyle>
+  <p:extLst>
+    <p:ext uri="{EFAFB233-063F-42B5-8137-9DF3F51BA10A}">
+      <p15:sldGuideLst xmlns:p15="http://schemas.microsoft.com/office/powerpoint/2012/main"/>
+    </p:ext>
+  </p:extLst>
 </p:presentation>
 </file>
 
@@ -115,16 +120,24 @@
   <pc:docChgLst>
     <pc:chgData name="Tobias Unger" userId="0a5458e38b5f4a0f" providerId="LiveId" clId="{5C6CAE59-BAC7-4E9C-B1A6-AA8C1CFC41BD}"/>
     <pc:docChg chg="custSel modSld">
-      <pc:chgData name="Tobias Unger" userId="0a5458e38b5f4a0f" providerId="LiveId" clId="{5C6CAE59-BAC7-4E9C-B1A6-AA8C1CFC41BD}" dt="2026-09-30T14:45:42.002" v="20" actId="1036"/>
+      <pc:chgData name="Tobias Unger" userId="0a5458e38b5f4a0f" providerId="LiveId" clId="{5C6CAE59-BAC7-4E9C-B1A6-AA8C1CFC41BD}" dt="2026-09-30T15:02:56.935" v="273" actId="1038"/>
       <pc:docMkLst>
         <pc:docMk/>
       </pc:docMkLst>
-      <pc:sldChg chg="modSp mod">
-        <pc:chgData name="Tobias Unger" userId="0a5458e38b5f4a0f" providerId="LiveId" clId="{5C6CAE59-BAC7-4E9C-B1A6-AA8C1CFC41BD}" dt="2026-09-30T14:45:42.002" v="20" actId="1036"/>
+      <pc:sldChg chg="addSp modSp mod">
+        <pc:chgData name="Tobias Unger" userId="0a5458e38b5f4a0f" providerId="LiveId" clId="{5C6CAE59-BAC7-4E9C-B1A6-AA8C1CFC41BD}" dt="2026-09-30T15:02:56.935" v="273" actId="1038"/>
         <pc:sldMkLst>
           <pc:docMk/>
           <pc:sldMk cId="1236752206" sldId="256"/>
         </pc:sldMkLst>
+        <pc:spChg chg="mod">
+          <ac:chgData name="Tobias Unger" userId="0a5458e38b5f4a0f" providerId="LiveId" clId="{5C6CAE59-BAC7-4E9C-B1A6-AA8C1CFC41BD}" dt="2026-09-30T14:58:56.412" v="156" actId="255"/>
+          <ac:spMkLst>
+            <pc:docMk/>
+            <pc:sldMk cId="1236752206" sldId="256"/>
+            <ac:spMk id="4" creationId="{44D8D4E4-018A-4A1A-9AE7-C2BE91536182}"/>
+          </ac:spMkLst>
+        </pc:spChg>
         <pc:spChg chg="mod">
           <ac:chgData name="Tobias Unger" userId="0a5458e38b5f4a0f" providerId="LiveId" clId="{5C6CAE59-BAC7-4E9C-B1A6-AA8C1CFC41BD}" dt="2026-09-30T14:45:21.652" v="2" actId="14100"/>
           <ac:spMkLst>
@@ -149,6 +162,86 @@
             <ac:spMk id="12" creationId="{10FAA03F-3EA9-4F20-B0C9-11D4021E116D}"/>
           </ac:spMkLst>
         </pc:spChg>
+        <pc:spChg chg="mod">
+          <ac:chgData name="Tobias Unger" userId="0a5458e38b5f4a0f" providerId="LiveId" clId="{5C6CAE59-BAC7-4E9C-B1A6-AA8C1CFC41BD}" dt="2026-09-30T14:59:04.270" v="174" actId="1037"/>
+          <ac:spMkLst>
+            <pc:docMk/>
+            <pc:sldMk cId="1236752206" sldId="256"/>
+            <ac:spMk id="15" creationId="{FC87284D-77F4-4DBC-B33F-AECF4C840C2A}"/>
+          </ac:spMkLst>
+        </pc:spChg>
+        <pc:spChg chg="mod">
+          <ac:chgData name="Tobias Unger" userId="0a5458e38b5f4a0f" providerId="LiveId" clId="{5C6CAE59-BAC7-4E9C-B1A6-AA8C1CFC41BD}" dt="2026-09-30T15:02:56.935" v="273" actId="1038"/>
+          <ac:spMkLst>
+            <pc:docMk/>
+            <pc:sldMk cId="1236752206" sldId="256"/>
+            <ac:spMk id="25" creationId="{B7F6BE5C-FCBB-4D57-8345-AB4146AFF4CB}"/>
+          </ac:spMkLst>
+        </pc:spChg>
+        <pc:spChg chg="mod">
+          <ac:chgData name="Tobias Unger" userId="0a5458e38b5f4a0f" providerId="LiveId" clId="{5C6CAE59-BAC7-4E9C-B1A6-AA8C1CFC41BD}" dt="2026-09-30T14:56:37.469" v="24" actId="27636"/>
+          <ac:spMkLst>
+            <pc:docMk/>
+            <pc:sldMk cId="1236752206" sldId="256"/>
+            <ac:spMk id="28" creationId="{EED477B3-B996-40D1-8764-BAAA9CA1AA28}"/>
+          </ac:spMkLst>
+        </pc:spChg>
+        <pc:spChg chg="mod">
+          <ac:chgData name="Tobias Unger" userId="0a5458e38b5f4a0f" providerId="LiveId" clId="{5C6CAE59-BAC7-4E9C-B1A6-AA8C1CFC41BD}" dt="2026-09-30T14:56:35.239" v="22" actId="27636"/>
+          <ac:spMkLst>
+            <pc:docMk/>
+            <pc:sldMk cId="1236752206" sldId="256"/>
+            <ac:spMk id="29" creationId="{B2AC6D41-3D3E-4699-95AB-777A228A5463}"/>
+          </ac:spMkLst>
+        </pc:spChg>
+        <pc:spChg chg="mod">
+          <ac:chgData name="Tobias Unger" userId="0a5458e38b5f4a0f" providerId="LiveId" clId="{5C6CAE59-BAC7-4E9C-B1A6-AA8C1CFC41BD}" dt="2026-09-30T14:56:46.968" v="31" actId="20577"/>
+          <ac:spMkLst>
+            <pc:docMk/>
+            <pc:sldMk cId="1236752206" sldId="256"/>
+            <ac:spMk id="30" creationId="{4EAD5ADE-51AA-4C3D-884A-43E24CCC6FB5}"/>
+          </ac:spMkLst>
+        </pc:spChg>
+        <pc:spChg chg="mod">
+          <ac:chgData name="Tobias Unger" userId="0a5458e38b5f4a0f" providerId="LiveId" clId="{5C6CAE59-BAC7-4E9C-B1A6-AA8C1CFC41BD}" dt="2026-09-30T14:58:56.412" v="156" actId="255"/>
+          <ac:spMkLst>
+            <pc:docMk/>
+            <pc:sldMk cId="1236752206" sldId="256"/>
+            <ac:spMk id="31" creationId="{F7A87BEA-EBC2-4DA8-9FD0-9D0DDCC4A053}"/>
+          </ac:spMkLst>
+        </pc:spChg>
+        <pc:spChg chg="mod">
+          <ac:chgData name="Tobias Unger" userId="0a5458e38b5f4a0f" providerId="LiveId" clId="{5C6CAE59-BAC7-4E9C-B1A6-AA8C1CFC41BD}" dt="2026-09-30T15:00:10.288" v="257" actId="20577"/>
+          <ac:spMkLst>
+            <pc:docMk/>
+            <pc:sldMk cId="1236752206" sldId="256"/>
+            <ac:spMk id="32" creationId="{D838A484-4BA3-40BD-B393-EF72F5242589}"/>
+          </ac:spMkLst>
+        </pc:spChg>
+        <pc:spChg chg="mod">
+          <ac:chgData name="Tobias Unger" userId="0a5458e38b5f4a0f" providerId="LiveId" clId="{5C6CAE59-BAC7-4E9C-B1A6-AA8C1CFC41BD}" dt="2026-09-30T14:59:15.373" v="177" actId="14100"/>
+          <ac:spMkLst>
+            <pc:docMk/>
+            <pc:sldMk cId="1236752206" sldId="256"/>
+            <ac:spMk id="33" creationId="{FB322598-55E3-4F1D-B987-E8C76E8A8F53}"/>
+          </ac:spMkLst>
+        </pc:spChg>
+        <pc:spChg chg="mod">
+          <ac:chgData name="Tobias Unger" userId="0a5458e38b5f4a0f" providerId="LiveId" clId="{5C6CAE59-BAC7-4E9C-B1A6-AA8C1CFC41BD}" dt="2026-09-30T15:00:01.925" v="255" actId="1036"/>
+          <ac:spMkLst>
+            <pc:docMk/>
+            <pc:sldMk cId="1236752206" sldId="256"/>
+            <ac:spMk id="34" creationId="{70C14F97-9C6D-42E5-8ABE-582A49F42697}"/>
+          </ac:spMkLst>
+        </pc:spChg>
+        <pc:cxnChg chg="add mod">
+          <ac:chgData name="Tobias Unger" userId="0a5458e38b5f4a0f" providerId="LiveId" clId="{5C6CAE59-BAC7-4E9C-B1A6-AA8C1CFC41BD}" dt="2026-09-30T14:59:52.981" v="218" actId="1036"/>
+          <ac:cxnSpMkLst>
+            <pc:docMk/>
+            <pc:sldMk cId="1236752206" sldId="256"/>
+            <ac:cxnSpMk id="36" creationId="{0B769186-3993-514E-2AF1-9197AE28B97C}"/>
+          </ac:cxnSpMkLst>
+        </pc:cxnChg>
       </pc:sldChg>
     </pc:docChg>
   </pc:docChgLst>
@@ -777,7 +870,7 @@
         </p:nvSpPr>
         <p:spPr>
           <a:xfrm>
-            <a:off x="609600" y="495300"/>
+            <a:off x="609600" y="1544712"/>
             <a:ext cx="1905000" cy="323850"/>
           </a:xfrm>
           <a:prstGeom prst="rect">
@@ -791,7 +884,7 @@
         </p:spPr>
         <p:txBody>
           <a:bodyPr>
-            <a:normAutofit fontScale="84722"/>
+            <a:normAutofit fontScale="92222" lnSpcReduction="20000"/>
           </a:bodyPr>
           <a:lstStyle/>
           <a:p>
@@ -806,7 +899,7 @@
               </a:defRPr>
             </a:pPr>
             <a:r>
-              <a:rPr sz="1800" b="1">
+              <a:rPr sz="1800" b="1" dirty="0" err="1">
                 <a:solidFill>
                   <a:srgbClr val="5C6770"/>
                 </a:solidFill>
@@ -816,6 +909,14 @@
               </a:rPr>
               <a:t>Seitenansicht</a:t>
             </a:r>
+            <a:endParaRPr sz="1800" b="1" dirty="0">
+              <a:solidFill>
+                <a:srgbClr val="5C6770"/>
+              </a:solidFill>
+              <a:latin typeface="Arial"/>
+              <a:ea typeface="Arial"/>
+              <a:cs typeface="Arial"/>
+            </a:endParaRPr>
           </a:p>
         </p:txBody>
       </p:sp>
@@ -901,8 +1002,8 @@
         </p:nvSpPr>
         <p:spPr>
           <a:xfrm>
-            <a:off x="4619625" y="5429250"/>
-            <a:ext cx="2476500" cy="266700"/>
+            <a:off x="4619625" y="5429249"/>
+            <a:ext cx="2476500" cy="316573"/>
           </a:xfrm>
           <a:prstGeom prst="rect">
             <a:avLst/>
@@ -915,7 +1016,7 @@
         </p:spPr>
         <p:txBody>
           <a:bodyPr>
-            <a:normAutofit fontScale="85185"/>
+            <a:normAutofit fontScale="92685"/>
           </a:bodyPr>
           <a:lstStyle/>
           <a:p>
@@ -930,7 +1031,7 @@
               </a:defRPr>
             </a:pPr>
             <a:r>
-              <a:rPr sz="1350" b="0">
+              <a:rPr sz="1200" b="0" dirty="0" err="1">
                 <a:solidFill>
                   <a:srgbClr val="5C6770"/>
                 </a:solidFill>
@@ -940,6 +1041,14 @@
               </a:rPr>
               <a:t>Förderbandebene</a:t>
             </a:r>
+            <a:endParaRPr sz="1200" b="0" dirty="0">
+              <a:solidFill>
+                <a:srgbClr val="5C6770"/>
+              </a:solidFill>
+              <a:latin typeface="Arial"/>
+              <a:ea typeface="Arial"/>
+              <a:cs typeface="Arial"/>
+            </a:endParaRPr>
           </a:p>
         </p:txBody>
       </p:sp>
@@ -1341,7 +1450,7 @@
         </p:nvSpPr>
         <p:spPr>
           <a:xfrm>
-            <a:off x="1143000" y="5429250"/>
+            <a:off x="719549" y="4576217"/>
             <a:ext cx="1905000" cy="228600"/>
           </a:xfrm>
           <a:prstGeom prst="rect">
@@ -1355,7 +1464,7 @@
         </p:spPr>
         <p:txBody>
           <a:bodyPr>
-            <a:normAutofit fontScale="75000"/>
+            <a:noAutofit/>
           </a:bodyPr>
           <a:lstStyle/>
           <a:p>
@@ -1370,7 +1479,7 @@
               </a:defRPr>
             </a:pPr>
             <a:r>
-              <a:rPr sz="1200" b="0">
+              <a:rPr sz="1200" b="0" dirty="0" err="1">
                 <a:solidFill>
                   <a:srgbClr val="5C6770"/>
                 </a:solidFill>
@@ -1380,6 +1489,14 @@
               </a:rPr>
               <a:t>Roboterbasis</a:t>
             </a:r>
+            <a:endParaRPr sz="1200" b="0" dirty="0">
+              <a:solidFill>
+                <a:srgbClr val="5C6770"/>
+              </a:solidFill>
+              <a:latin typeface="Arial"/>
+              <a:ea typeface="Arial"/>
+              <a:cs typeface="Arial"/>
+            </a:endParaRPr>
           </a:p>
         </p:txBody>
       </p:sp>
@@ -1798,8 +1915,8 @@
         </p:nvSpPr>
         <p:spPr>
           <a:xfrm>
-            <a:off x="2543175" y="5010150"/>
-            <a:ext cx="95250" cy="95250"/>
+            <a:off x="2398382" y="4870024"/>
+            <a:ext cx="360000" cy="360000"/>
           </a:xfrm>
           <a:prstGeom prst="ellipse">
             <a:avLst/>
@@ -1911,7 +2028,7 @@
         </p:spPr>
         <p:txBody>
           <a:bodyPr>
-            <a:normAutofit fontScale="70588"/>
+            <a:normAutofit fontScale="78088" lnSpcReduction="10000"/>
           </a:bodyPr>
           <a:lstStyle/>
           <a:p>
@@ -1926,7 +2043,7 @@
               </a:defRPr>
             </a:pPr>
             <a:r>
-              <a:rPr sz="1275" b="1">
+              <a:rPr sz="1275" b="1" dirty="0">
                 <a:solidFill>
                   <a:srgbClr val="147EAE"/>
                 </a:solidFill>
@@ -1934,7 +2051,29 @@
                 <a:ea typeface="Arial"/>
                 <a:cs typeface="Arial"/>
               </a:rPr>
-              <a:t>world-Y−</a:t>
+              <a:t>world-</a:t>
+            </a:r>
+            <a:r>
+              <a:rPr lang="de-DE" sz="1275" b="1" dirty="0">
+                <a:solidFill>
+                  <a:srgbClr val="147EAE"/>
+                </a:solidFill>
+                <a:latin typeface="Arial"/>
+                <a:ea typeface="Arial"/>
+                <a:cs typeface="Arial"/>
+              </a:rPr>
+              <a:t> </a:t>
+            </a:r>
+            <a:r>
+              <a:rPr sz="1275" b="1" dirty="0">
+                <a:solidFill>
+                  <a:srgbClr val="147EAE"/>
+                </a:solidFill>
+                <a:latin typeface="Arial"/>
+                <a:ea typeface="Arial"/>
+                <a:cs typeface="Arial"/>
+              </a:rPr>
+              <a:t>Y−</a:t>
             </a:r>
           </a:p>
         </p:txBody>
@@ -1969,7 +2108,7 @@
         </p:spPr>
         <p:txBody>
           <a:bodyPr>
-            <a:normAutofit fontScale="70588"/>
+            <a:normAutofit fontScale="78088" lnSpcReduction="10000"/>
           </a:bodyPr>
           <a:lstStyle/>
           <a:p>
@@ -1984,7 +2123,7 @@
               </a:defRPr>
             </a:pPr>
             <a:r>
-              <a:rPr sz="1275" b="1">
+              <a:rPr sz="1275" b="1" dirty="0">
                 <a:solidFill>
                   <a:srgbClr val="147EAE"/>
                 </a:solidFill>
@@ -1992,7 +2131,29 @@
                 <a:ea typeface="Arial"/>
                 <a:cs typeface="Arial"/>
               </a:rPr>
-              <a:t>world-Z+</a:t>
+              <a:t>world-</a:t>
+            </a:r>
+            <a:r>
+              <a:rPr lang="de-DE" sz="1275" b="1" dirty="0">
+                <a:solidFill>
+                  <a:srgbClr val="147EAE"/>
+                </a:solidFill>
+                <a:latin typeface="Arial"/>
+                <a:ea typeface="Arial"/>
+                <a:cs typeface="Arial"/>
+              </a:rPr>
+              <a:t> </a:t>
+            </a:r>
+            <a:r>
+              <a:rPr sz="1275" b="1" dirty="0">
+                <a:solidFill>
+                  <a:srgbClr val="147EAE"/>
+                </a:solidFill>
+                <a:latin typeface="Arial"/>
+                <a:ea typeface="Arial"/>
+                <a:cs typeface="Arial"/>
+              </a:rPr>
+              <a:t>Z+</a:t>
             </a:r>
           </a:p>
         </p:txBody>
@@ -2027,7 +2188,7 @@
         </p:spPr>
         <p:txBody>
           <a:bodyPr>
-            <a:normAutofit fontScale="64583"/>
+            <a:normAutofit fontScale="72083" lnSpcReduction="20000"/>
           </a:bodyPr>
           <a:lstStyle/>
           <a:p>
@@ -2042,7 +2203,7 @@
               </a:defRPr>
             </a:pPr>
             <a:r>
-              <a:rPr sz="1200" b="1">
+              <a:rPr lang="de-DE" sz="1200" b="1" dirty="0">
                 <a:solidFill>
                   <a:srgbClr val="147EAE"/>
                 </a:solidFill>
@@ -2050,8 +2211,27 @@
                 <a:ea typeface="Arial"/>
                 <a:cs typeface="Arial"/>
               </a:rPr>
-              <a:t>world</a:t>
-            </a:r>
+              <a:t>w</a:t>
+            </a:r>
+            <a:r>
+              <a:rPr sz="1200" b="1" dirty="0" err="1">
+                <a:solidFill>
+                  <a:srgbClr val="147EAE"/>
+                </a:solidFill>
+                <a:latin typeface="Arial"/>
+                <a:ea typeface="Arial"/>
+                <a:cs typeface="Arial"/>
+              </a:rPr>
+              <a:t>orld</a:t>
+            </a:r>
+            <a:endParaRPr sz="1200" b="1" dirty="0">
+              <a:solidFill>
+                <a:srgbClr val="147EAE"/>
+              </a:solidFill>
+              <a:latin typeface="Arial"/>
+              <a:ea typeface="Arial"/>
+              <a:cs typeface="Arial"/>
+            </a:endParaRPr>
           </a:p>
         </p:txBody>
       </p:sp>
@@ -2085,7 +2265,7 @@
         </p:spPr>
         <p:txBody>
           <a:bodyPr>
-            <a:normAutofit fontScale="85185"/>
+            <a:noAutofit/>
           </a:bodyPr>
           <a:lstStyle/>
           <a:p>
@@ -2100,7 +2280,7 @@
               </a:defRPr>
             </a:pPr>
             <a:r>
-              <a:rPr sz="1350" b="0">
+              <a:rPr sz="1200" b="0">
                 <a:solidFill>
                   <a:srgbClr val="5C6770"/>
                 </a:solidFill>
@@ -2143,7 +2323,7 @@
         </p:spPr>
         <p:txBody>
           <a:bodyPr>
-            <a:normAutofit fontScale="85491"/>
+            <a:noAutofit/>
           </a:bodyPr>
           <a:lstStyle/>
           <a:p>
@@ -2158,38 +2338,147 @@
               </a:defRPr>
             </a:pPr>
             <a:r>
-              <a:rPr sz="1275" b="0">
-                <a:solidFill>
-                  <a:srgbClr val="5C6770"/>
-                </a:solidFill>
-                <a:latin typeface="Arial"/>
-                <a:ea typeface="Arial"/>
-                <a:cs typeface="Arial"/>
-              </a:rPr>
-              <a:t>Der Greifer ist gegenüber dem Flansch</a:t>
-            </a:r>
-          </a:p>
-          <a:p>
-            <a:pPr>
-              <a:defRPr sz="1275" b="0">
-                <a:solidFill>
-                  <a:srgbClr val="5C6770"/>
-                </a:solidFill>
-                <a:latin typeface="Arial"/>
-                <a:ea typeface="Arial"/>
-                <a:cs typeface="Arial"/>
-              </a:defRPr>
-            </a:pPr>
-            <a:r>
-              <a:rPr sz="1275" b="0">
-                <a:solidFill>
-                  <a:srgbClr val="5C6770"/>
-                </a:solidFill>
-                <a:latin typeface="Arial"/>
-                <a:ea typeface="Arial"/>
-                <a:cs typeface="Arial"/>
-              </a:rPr>
-              <a:t>mechanisch angebaut.</a:t>
+              <a:rPr sz="1200" b="0" dirty="0">
+                <a:solidFill>
+                  <a:srgbClr val="5C6770"/>
+                </a:solidFill>
+                <a:latin typeface="Arial"/>
+                <a:ea typeface="Arial"/>
+                <a:cs typeface="Arial"/>
+              </a:rPr>
+              <a:t>Der </a:t>
+            </a:r>
+            <a:r>
+              <a:rPr sz="1200" b="0" dirty="0" err="1">
+                <a:solidFill>
+                  <a:srgbClr val="5C6770"/>
+                </a:solidFill>
+                <a:latin typeface="Arial"/>
+                <a:ea typeface="Arial"/>
+                <a:cs typeface="Arial"/>
+              </a:rPr>
+              <a:t>Greifer</a:t>
+            </a:r>
+            <a:r>
+              <a:rPr sz="1200" b="0" dirty="0">
+                <a:solidFill>
+                  <a:srgbClr val="5C6770"/>
+                </a:solidFill>
+                <a:latin typeface="Arial"/>
+                <a:ea typeface="Arial"/>
+                <a:cs typeface="Arial"/>
+              </a:rPr>
+              <a:t> </a:t>
+            </a:r>
+            <a:r>
+              <a:rPr sz="1200" b="0" dirty="0" err="1">
+                <a:solidFill>
+                  <a:srgbClr val="5C6770"/>
+                </a:solidFill>
+                <a:latin typeface="Arial"/>
+                <a:ea typeface="Arial"/>
+                <a:cs typeface="Arial"/>
+              </a:rPr>
+              <a:t>ist</a:t>
+            </a:r>
+            <a:r>
+              <a:rPr sz="1200" b="0" dirty="0">
+                <a:solidFill>
+                  <a:srgbClr val="5C6770"/>
+                </a:solidFill>
+                <a:latin typeface="Arial"/>
+                <a:ea typeface="Arial"/>
+                <a:cs typeface="Arial"/>
+              </a:rPr>
+              <a:t> </a:t>
+            </a:r>
+            <a:r>
+              <a:rPr sz="1200" b="0" dirty="0" err="1">
+                <a:solidFill>
+                  <a:srgbClr val="5C6770"/>
+                </a:solidFill>
+                <a:latin typeface="Arial"/>
+                <a:ea typeface="Arial"/>
+                <a:cs typeface="Arial"/>
+              </a:rPr>
+              <a:t>gegenüber</a:t>
+            </a:r>
+            <a:r>
+              <a:rPr sz="1200" b="0" dirty="0">
+                <a:solidFill>
+                  <a:srgbClr val="5C6770"/>
+                </a:solidFill>
+                <a:latin typeface="Arial"/>
+                <a:ea typeface="Arial"/>
+                <a:cs typeface="Arial"/>
+              </a:rPr>
+              <a:t> dem </a:t>
+            </a:r>
+            <a:r>
+              <a:rPr sz="1200" b="0" dirty="0" err="1">
+                <a:solidFill>
+                  <a:srgbClr val="5C6770"/>
+                </a:solidFill>
+                <a:latin typeface="Arial"/>
+                <a:ea typeface="Arial"/>
+                <a:cs typeface="Arial"/>
+              </a:rPr>
+              <a:t>Flansch</a:t>
+            </a:r>
+            <a:r>
+              <a:rPr lang="de-DE" sz="1200" dirty="0">
+                <a:solidFill>
+                  <a:srgbClr val="5C6770"/>
+                </a:solidFill>
+                <a:latin typeface="Arial"/>
+                <a:ea typeface="Arial"/>
+                <a:cs typeface="Arial"/>
+              </a:rPr>
+              <a:t> </a:t>
+            </a:r>
+            <a:r>
+              <a:rPr sz="1200" b="0" dirty="0" err="1">
+                <a:solidFill>
+                  <a:srgbClr val="5C6770"/>
+                </a:solidFill>
+                <a:latin typeface="Arial"/>
+                <a:ea typeface="Arial"/>
+                <a:cs typeface="Arial"/>
+              </a:rPr>
+              <a:t>mechanisch</a:t>
+            </a:r>
+            <a:r>
+              <a:rPr sz="1200" b="0" dirty="0">
+                <a:solidFill>
+                  <a:srgbClr val="5C6770"/>
+                </a:solidFill>
+                <a:latin typeface="Arial"/>
+                <a:ea typeface="Arial"/>
+                <a:cs typeface="Arial"/>
+              </a:rPr>
+              <a:t> </a:t>
+            </a:r>
+            <a:r>
+              <a:rPr sz="1200" b="0" dirty="0" err="1">
+                <a:solidFill>
+                  <a:srgbClr val="5C6770"/>
+                </a:solidFill>
+                <a:latin typeface="Arial"/>
+                <a:ea typeface="Arial"/>
+                <a:cs typeface="Arial"/>
+              </a:rPr>
+              <a:t>angebaut</a:t>
+            </a:r>
+            <a:r>
+              <a:rPr sz="1200" b="0" dirty="0">
+                <a:solidFill>
+                  <a:srgbClr val="5C6770"/>
+                </a:solidFill>
+                <a:latin typeface="Arial"/>
+                <a:ea typeface="Arial"/>
+                <a:cs typeface="Arial"/>
+              </a:rPr>
+              <a:t>.</a:t>
             </a:r>
           </a:p>
         </p:txBody>
@@ -2210,8 +2499,8 @@
         </p:nvSpPr>
         <p:spPr>
           <a:xfrm>
-            <a:off x="7810500" y="5581650"/>
-            <a:ext cx="3238500" cy="247650"/>
+            <a:off x="1244642" y="6112537"/>
+            <a:ext cx="8721703" cy="714375"/>
           </a:xfrm>
           <a:prstGeom prst="rect">
             <a:avLst/>
@@ -2224,11 +2513,11 @@
         </p:spPr>
         <p:txBody>
           <a:bodyPr>
-            <a:normAutofit fontScale="80392"/>
+            <a:normAutofit fontScale="95392"/>
           </a:bodyPr>
           <a:lstStyle/>
           <a:p>
-            <a:pPr>
+            <a:pPr algn="ctr">
               <a:defRPr sz="1275" b="0">
                 <a:solidFill>
                   <a:srgbClr val="5C6770"/>
@@ -2239,19 +2528,182 @@
               </a:defRPr>
             </a:pPr>
             <a:r>
-              <a:rPr sz="1275" b="0">
-                <a:solidFill>
-                  <a:srgbClr val="5C6770"/>
-                </a:solidFill>
-                <a:latin typeface="Arial"/>
-                <a:ea typeface="Arial"/>
-                <a:cs typeface="Arial"/>
-              </a:rPr>
-              <a:t>Die Förderbewegung folgt der Achse world-Y−.</a:t>
+              <a:rPr sz="1200" b="0" dirty="0">
+                <a:solidFill>
+                  <a:srgbClr val="5C6770"/>
+                </a:solidFill>
+                <a:latin typeface="Arial"/>
+                <a:ea typeface="Arial"/>
+                <a:cs typeface="Arial"/>
+              </a:rPr>
+              <a:t>Die </a:t>
+            </a:r>
+            <a:r>
+              <a:rPr sz="1200" b="0" dirty="0" err="1">
+                <a:solidFill>
+                  <a:srgbClr val="5C6770"/>
+                </a:solidFill>
+                <a:latin typeface="Arial"/>
+                <a:ea typeface="Arial"/>
+                <a:cs typeface="Arial"/>
+              </a:rPr>
+              <a:t>Förderbewegung</a:t>
+            </a:r>
+            <a:r>
+              <a:rPr sz="1200" b="0" dirty="0">
+                <a:solidFill>
+                  <a:srgbClr val="5C6770"/>
+                </a:solidFill>
+                <a:latin typeface="Arial"/>
+                <a:ea typeface="Arial"/>
+                <a:cs typeface="Arial"/>
+              </a:rPr>
+              <a:t> </a:t>
+            </a:r>
+            <a:r>
+              <a:rPr sz="1200" b="0" dirty="0" err="1">
+                <a:solidFill>
+                  <a:srgbClr val="5C6770"/>
+                </a:solidFill>
+                <a:latin typeface="Arial"/>
+                <a:ea typeface="Arial"/>
+                <a:cs typeface="Arial"/>
+              </a:rPr>
+              <a:t>folgt</a:t>
+            </a:r>
+            <a:r>
+              <a:rPr sz="1200" b="0" dirty="0">
+                <a:solidFill>
+                  <a:srgbClr val="5C6770"/>
+                </a:solidFill>
+                <a:latin typeface="Arial"/>
+                <a:ea typeface="Arial"/>
+                <a:cs typeface="Arial"/>
+              </a:rPr>
+              <a:t> der </a:t>
+            </a:r>
+            <a:r>
+              <a:rPr lang="de-DE" sz="1200" b="0" dirty="0">
+                <a:solidFill>
+                  <a:srgbClr val="5C6770"/>
+                </a:solidFill>
+                <a:latin typeface="Arial"/>
+                <a:ea typeface="Arial"/>
+                <a:cs typeface="Arial"/>
+              </a:rPr>
+              <a:t>Y-</a:t>
+            </a:r>
+            <a:r>
+              <a:rPr sz="1200" b="0" dirty="0" err="1">
+                <a:solidFill>
+                  <a:srgbClr val="5C6770"/>
+                </a:solidFill>
+                <a:latin typeface="Arial"/>
+                <a:ea typeface="Arial"/>
+                <a:cs typeface="Arial"/>
+              </a:rPr>
+              <a:t>Achse</a:t>
+            </a:r>
+            <a:r>
+              <a:rPr sz="1200" b="0" dirty="0">
+                <a:solidFill>
+                  <a:srgbClr val="5C6770"/>
+                </a:solidFill>
+                <a:latin typeface="Arial"/>
+                <a:ea typeface="Arial"/>
+                <a:cs typeface="Arial"/>
+              </a:rPr>
+              <a:t> </a:t>
+            </a:r>
+            <a:r>
+              <a:rPr lang="de-DE" sz="1200" b="0" dirty="0">
+                <a:solidFill>
+                  <a:srgbClr val="5C6770"/>
+                </a:solidFill>
+                <a:latin typeface="Arial"/>
+                <a:ea typeface="Arial"/>
+                <a:cs typeface="Arial"/>
+              </a:rPr>
+              <a:t>im </a:t>
+            </a:r>
+            <a:r>
+              <a:rPr sz="1200" b="0" dirty="0">
+                <a:solidFill>
+                  <a:srgbClr val="5C6770"/>
+                </a:solidFill>
+                <a:latin typeface="Arial"/>
+                <a:ea typeface="Arial"/>
+                <a:cs typeface="Arial"/>
+              </a:rPr>
+              <a:t>world</a:t>
+            </a:r>
+            <a:r>
+              <a:rPr lang="de-DE" sz="1200" b="0" dirty="0">
+                <a:solidFill>
+                  <a:srgbClr val="5C6770"/>
+                </a:solidFill>
+                <a:latin typeface="Arial"/>
+                <a:ea typeface="Arial"/>
+                <a:cs typeface="Arial"/>
+              </a:rPr>
+              <a:t>-System in negative Richtung</a:t>
+            </a:r>
+            <a:r>
+              <a:rPr sz="1200" b="0" dirty="0">
+                <a:solidFill>
+                  <a:srgbClr val="5C6770"/>
+                </a:solidFill>
+                <a:latin typeface="Arial"/>
+                <a:ea typeface="Arial"/>
+                <a:cs typeface="Arial"/>
+              </a:rPr>
+              <a:t>.</a:t>
             </a:r>
           </a:p>
         </p:txBody>
       </p:sp>
+      <p:cxnSp>
+        <p:nvCxnSpPr>
+          <p:cNvPr id="36" name="Gerade Verbindung mit Pfeil 35">
+            <a:extLst>
+              <a:ext uri="{FF2B5EF4-FFF2-40B4-BE49-F238E27FC236}">
+                <a16:creationId xmlns:a16="http://schemas.microsoft.com/office/drawing/2014/main" id="{0B769186-3993-514E-2AF1-9197AE28B97C}"/>
+              </a:ext>
+            </a:extLst>
+          </p:cNvPr>
+          <p:cNvCxnSpPr/>
+          <p:nvPr/>
+        </p:nvCxnSpPr>
+        <p:spPr>
+          <a:xfrm flipH="1">
+            <a:off x="1301025" y="6045030"/>
+            <a:ext cx="9493804" cy="0"/>
+          </a:xfrm>
+          <a:prstGeom prst="straightConnector1">
+            <a:avLst/>
+          </a:prstGeom>
+          <a:ln w="76200">
+            <a:solidFill>
+              <a:schemeClr val="accent2"/>
+            </a:solidFill>
+            <a:tailEnd type="triangle"/>
+          </a:ln>
+        </p:spPr>
+        <p:style>
+          <a:lnRef idx="1">
+            <a:schemeClr val="accent1"/>
+          </a:lnRef>
+          <a:fillRef idx="0">
+            <a:schemeClr val="accent1"/>
+          </a:fillRef>
+          <a:effectRef idx="0">
+            <a:schemeClr val="accent1"/>
+          </a:effectRef>
+          <a:fontRef idx="minor">
+            <a:schemeClr val="tx1"/>
+          </a:fontRef>
+        </p:style>
+      </p:cxnSp>
     </p:spTree>
     <p:extLst>
       <p:ext uri="{BB962C8B-B14F-4D97-AF65-F5344CB8AC3E}">

</xml_diff>